<commit_message>
Completely BTTH5 HOI QUY PHI TUYEN TINH
</commit_message>
<xml_diff>
--- a/Document/Gioi_Thieu_De_Tai.pptx
+++ b/Document/Gioi_Thieu_De_Tai.pptx
@@ -21,24 +21,12 @@
   <p:notesSz cx="6858000" cy="9144000"/>
   <p:embeddedFontLst>
     <p:embeddedFont>
-      <p:font typeface="Canva Sans Bold" charset="1" panose="020B0803030501040103"/>
+      <p:font typeface="Times New Roman Bold" charset="1" panose="02030802070405020303"/>
       <p:regular r:id="rId17"/>
     </p:embeddedFont>
     <p:embeddedFont>
-      <p:font typeface="Canva Sans" charset="1" panose="020B0503030501040103"/>
+      <p:font typeface="Times New Roman" charset="1" panose="02030502070405020303"/>
       <p:regular r:id="rId18"/>
-    </p:embeddedFont>
-    <p:embeddedFont>
-      <p:font typeface="Glacial Indifference Bold" charset="1" panose="00000800000000000000"/>
-      <p:regular r:id="rId19"/>
-    </p:embeddedFont>
-    <p:embeddedFont>
-      <p:font typeface="Bernoru" charset="1" panose="00000A00000000000000"/>
-      <p:regular r:id="rId20"/>
-    </p:embeddedFont>
-    <p:embeddedFont>
-      <p:font typeface="Glacial Indifference" charset="1" panose="00000000000000000000"/>
-      <p:regular r:id="rId21"/>
     </p:embeddedFont>
   </p:embeddedFontLst>
   <p:defaultTextStyle>
@@ -4094,8 +4082,8 @@
         </p:nvSpPr>
         <p:spPr>
           <a:xfrm rot="0">
-            <a:off x="3540939" y="3949693"/>
-            <a:ext cx="10900975" cy="101175052"/>
+            <a:off x="3540939" y="3854443"/>
+            <a:ext cx="10900975" cy="101270302"/>
           </a:xfrm>
           <a:prstGeom prst="rect">
             <a:avLst/>
@@ -4117,10 +4105,10 @@
                 <a:solidFill>
                   <a:srgbClr val="863434"/>
                 </a:solidFill>
-                <a:latin typeface="Canva Sans Bold"/>
-                <a:ea typeface="Canva Sans Bold"/>
-                <a:cs typeface="Canva Sans Bold"/>
-                <a:sym typeface="Canva Sans Bold"/>
+                <a:latin typeface="Times New Roman Bold"/>
+                <a:ea typeface="Times New Roman Bold"/>
+                <a:cs typeface="Times New Roman Bold"/>
+                <a:sym typeface="Times New Roman Bold"/>
               </a:rPr>
               <a:t>GVHD: Dương Phi Long</a:t>
             </a:r>
@@ -4136,12 +4124,12 @@
                 <a:solidFill>
                   <a:srgbClr val="863434"/>
                 </a:solidFill>
-                <a:latin typeface="Canva Sans"/>
-                <a:ea typeface="Canva Sans"/>
-                <a:cs typeface="Canva Sans"/>
-                <a:sym typeface="Canva Sans"/>
+                <a:latin typeface="Times New Roman"/>
+                <a:ea typeface="Times New Roman"/>
+                <a:cs typeface="Times New Roman"/>
+                <a:sym typeface="Times New Roman"/>
               </a:rPr>
-              <a:t>Vũ Minh Đức - 22520277</a:t>
+              <a:t>Vũ Minh Đức             - 22520277</a:t>
             </a:r>
           </a:p>
           <a:p>
@@ -4155,10 +4143,10 @@
                 <a:solidFill>
                   <a:srgbClr val="863434"/>
                 </a:solidFill>
-                <a:latin typeface="Canva Sans"/>
-                <a:ea typeface="Canva Sans"/>
-                <a:cs typeface="Canva Sans"/>
-                <a:sym typeface="Canva Sans"/>
+                <a:latin typeface="Times New Roman"/>
+                <a:ea typeface="Times New Roman"/>
+                <a:cs typeface="Times New Roman"/>
+                <a:sym typeface="Times New Roman"/>
               </a:rPr>
               <a:t>Nguyễn Thị Thuý Vy - 22521706</a:t>
             </a:r>
@@ -4174,12 +4162,12 @@
                 <a:solidFill>
                   <a:srgbClr val="863434"/>
                 </a:solidFill>
-                <a:latin typeface="Canva Sans"/>
-                <a:ea typeface="Canva Sans"/>
-                <a:cs typeface="Canva Sans"/>
-                <a:sym typeface="Canva Sans"/>
+                <a:latin typeface="Times New Roman"/>
+                <a:ea typeface="Times New Roman"/>
+                <a:cs typeface="Times New Roman"/>
+                <a:sym typeface="Times New Roman"/>
               </a:rPr>
-              <a:t>Phan Thị Tường Vi - 22521658</a:t>
+              <a:t>Phan Thị Tường Vi    - 22521658</a:t>
             </a:r>
           </a:p>
           <a:p>
@@ -4193,12 +4181,12 @@
                 <a:solidFill>
                   <a:srgbClr val="863434"/>
                 </a:solidFill>
-                <a:latin typeface="Canva Sans"/>
-                <a:ea typeface="Canva Sans"/>
-                <a:cs typeface="Canva Sans"/>
-                <a:sym typeface="Canva Sans"/>
+                <a:latin typeface="Times New Roman"/>
+                <a:ea typeface="Times New Roman"/>
+                <a:cs typeface="Times New Roman"/>
+                <a:sym typeface="Times New Roman"/>
               </a:rPr>
-              <a:t>Lê Thị Ánh Xuân -  22521714</a:t>
+              <a:t> Lê Thị Ánh Xuân       - 22521714</a:t>
             </a:r>
           </a:p>
           <a:p>
@@ -4492,10 +4480,10 @@
                 <a:solidFill>
                   <a:srgbClr val="863434"/>
                 </a:solidFill>
-                <a:latin typeface="Glacial Indifference Bold"/>
-                <a:ea typeface="Glacial Indifference Bold"/>
-                <a:cs typeface="Glacial Indifference Bold"/>
-                <a:sym typeface="Glacial Indifference Bold"/>
+                <a:latin typeface="Times New Roman Bold"/>
+                <a:ea typeface="Times New Roman Bold"/>
+                <a:cs typeface="Times New Roman Bold"/>
+                <a:sym typeface="Times New Roman Bold"/>
               </a:rPr>
               <a:t> </a:t>
             </a:r>
@@ -4525,10 +4513,10 @@
                 <a:solidFill>
                   <a:srgbClr val="863434"/>
                 </a:solidFill>
-                <a:latin typeface="Glacial Indifference Bold"/>
-                <a:ea typeface="Glacial Indifference Bold"/>
-                <a:cs typeface="Glacial Indifference Bold"/>
-                <a:sym typeface="Glacial Indifference Bold"/>
+                <a:latin typeface="Times New Roman Bold"/>
+                <a:ea typeface="Times New Roman Bold"/>
+                <a:cs typeface="Times New Roman Bold"/>
+                <a:sym typeface="Times New Roman Bold"/>
               </a:rPr>
               <a:t>ĐĂNG KÝ NHÓM</a:t>
             </a:r>
@@ -4551,10 +4539,10 @@
                 <a:solidFill>
                   <a:srgbClr val="863434"/>
                 </a:solidFill>
-                <a:latin typeface="Glacial Indifference Bold"/>
-                <a:ea typeface="Glacial Indifference Bold"/>
-                <a:cs typeface="Glacial Indifference Bold"/>
-                <a:sym typeface="Glacial Indifference Bold"/>
+                <a:latin typeface="Times New Roman Bold"/>
+                <a:ea typeface="Times New Roman Bold"/>
+                <a:cs typeface="Times New Roman Bold"/>
+                <a:sym typeface="Times New Roman Bold"/>
               </a:rPr>
               <a:t>THỜI GIAN BÁO CÁO</a:t>
             </a:r>
@@ -4584,10 +4572,10 @@
                 <a:solidFill>
                   <a:srgbClr val="863434"/>
                 </a:solidFill>
-                <a:latin typeface="Glacial Indifference Bold"/>
-                <a:ea typeface="Glacial Indifference Bold"/>
-                <a:cs typeface="Glacial Indifference Bold"/>
-                <a:sym typeface="Glacial Indifference Bold"/>
+                <a:latin typeface="Times New Roman Bold"/>
+                <a:ea typeface="Times New Roman Bold"/>
+                <a:cs typeface="Times New Roman Bold"/>
+                <a:sym typeface="Times New Roman Bold"/>
               </a:rPr>
               <a:t>DS LOP - Điểm BT LT</a:t>
             </a:r>
@@ -4617,10 +4605,10 @@
                 <a:solidFill>
                   <a:srgbClr val="863434"/>
                 </a:solidFill>
-                <a:latin typeface="Glacial Indifference Bold"/>
-                <a:ea typeface="Glacial Indifference Bold"/>
-                <a:cs typeface="Glacial Indifference Bold"/>
-                <a:sym typeface="Glacial Indifference Bold"/>
+                <a:latin typeface="Times New Roman Bold"/>
+                <a:ea typeface="Times New Roman Bold"/>
+                <a:cs typeface="Times New Roman Bold"/>
+                <a:sym typeface="Times New Roman Bold"/>
               </a:rPr>
               <a:t>DS LỚP</a:t>
             </a:r>
@@ -4671,10 +4659,10 @@
                 <a:solidFill>
                   <a:srgbClr val="863434"/>
                 </a:solidFill>
-                <a:latin typeface="Glacial Indifference Bold"/>
-                <a:ea typeface="Glacial Indifference Bold"/>
-                <a:cs typeface="Glacial Indifference Bold"/>
-                <a:sym typeface="Glacial Indifference Bold"/>
+                <a:latin typeface="Times New Roman Bold"/>
+                <a:ea typeface="Times New Roman Bold"/>
+                <a:cs typeface="Times New Roman Bold"/>
+                <a:sym typeface="Times New Roman Bold"/>
               </a:rPr>
               <a:t>Phan Thị Tường Vi</a:t>
             </a:r>
@@ -4704,10 +4692,10 @@
                 <a:solidFill>
                   <a:srgbClr val="863434"/>
                 </a:solidFill>
-                <a:latin typeface="Glacial Indifference Bold"/>
-                <a:ea typeface="Glacial Indifference Bold"/>
-                <a:cs typeface="Glacial Indifference Bold"/>
-                <a:sym typeface="Glacial Indifference Bold"/>
+                <a:latin typeface="Times New Roman Bold"/>
+                <a:ea typeface="Times New Roman Bold"/>
+                <a:cs typeface="Times New Roman Bold"/>
+                <a:sym typeface="Times New Roman Bold"/>
               </a:rPr>
               <a:t> </a:t>
             </a:r>
@@ -5003,10 +4991,10 @@
                 <a:solidFill>
                   <a:srgbClr val="863434"/>
                 </a:solidFill>
-                <a:latin typeface="Glacial Indifference Bold"/>
-                <a:ea typeface="Glacial Indifference Bold"/>
-                <a:cs typeface="Glacial Indifference Bold"/>
-                <a:sym typeface="Glacial Indifference Bold"/>
+                <a:latin typeface="Times New Roman Bold"/>
+                <a:ea typeface="Times New Roman Bold"/>
+                <a:cs typeface="Times New Roman Bold"/>
+                <a:sym typeface="Times New Roman Bold"/>
               </a:rPr>
               <a:t> </a:t>
             </a:r>
@@ -5036,10 +5024,10 @@
                 <a:solidFill>
                   <a:srgbClr val="863434"/>
                 </a:solidFill>
-                <a:latin typeface="Glacial Indifference Bold"/>
-                <a:ea typeface="Glacial Indifference Bold"/>
-                <a:cs typeface="Glacial Indifference Bold"/>
-                <a:sym typeface="Glacial Indifference Bold"/>
+                <a:latin typeface="Times New Roman Bold"/>
+                <a:ea typeface="Times New Roman Bold"/>
+                <a:cs typeface="Times New Roman Bold"/>
+                <a:sym typeface="Times New Roman Bold"/>
               </a:rPr>
               <a:t>ĐĂNG KÝ NHÓM</a:t>
             </a:r>
@@ -5062,10 +5050,10 @@
                 <a:solidFill>
                   <a:srgbClr val="863434"/>
                 </a:solidFill>
-                <a:latin typeface="Glacial Indifference Bold"/>
-                <a:ea typeface="Glacial Indifference Bold"/>
-                <a:cs typeface="Glacial Indifference Bold"/>
-                <a:sym typeface="Glacial Indifference Bold"/>
+                <a:latin typeface="Times New Roman Bold"/>
+                <a:ea typeface="Times New Roman Bold"/>
+                <a:cs typeface="Times New Roman Bold"/>
+                <a:sym typeface="Times New Roman Bold"/>
               </a:rPr>
               <a:t>THỜI GIAN BÁO CÁO</a:t>
             </a:r>
@@ -5095,10 +5083,10 @@
                 <a:solidFill>
                   <a:srgbClr val="863434"/>
                 </a:solidFill>
-                <a:latin typeface="Glacial Indifference Bold"/>
-                <a:ea typeface="Glacial Indifference Bold"/>
-                <a:cs typeface="Glacial Indifference Bold"/>
-                <a:sym typeface="Glacial Indifference Bold"/>
+                <a:latin typeface="Times New Roman Bold"/>
+                <a:ea typeface="Times New Roman Bold"/>
+                <a:cs typeface="Times New Roman Bold"/>
+                <a:sym typeface="Times New Roman Bold"/>
               </a:rPr>
               <a:t>DS LOP - Điểm BT LT</a:t>
             </a:r>
@@ -5128,10 +5116,10 @@
                 <a:solidFill>
                   <a:srgbClr val="863434"/>
                 </a:solidFill>
-                <a:latin typeface="Glacial Indifference Bold"/>
-                <a:ea typeface="Glacial Indifference Bold"/>
-                <a:cs typeface="Glacial Indifference Bold"/>
-                <a:sym typeface="Glacial Indifference Bold"/>
+                <a:latin typeface="Times New Roman Bold"/>
+                <a:ea typeface="Times New Roman Bold"/>
+                <a:cs typeface="Times New Roman Bold"/>
+                <a:sym typeface="Times New Roman Bold"/>
               </a:rPr>
               <a:t>DS LỚP</a:t>
             </a:r>
@@ -5182,10 +5170,10 @@
                 <a:solidFill>
                   <a:srgbClr val="863434"/>
                 </a:solidFill>
-                <a:latin typeface="Glacial Indifference Bold"/>
-                <a:ea typeface="Glacial Indifference Bold"/>
-                <a:cs typeface="Glacial Indifference Bold"/>
-                <a:sym typeface="Glacial Indifference Bold"/>
+                <a:latin typeface="Times New Roman Bold"/>
+                <a:ea typeface="Times New Roman Bold"/>
+                <a:cs typeface="Times New Roman Bold"/>
+                <a:sym typeface="Times New Roman Bold"/>
               </a:rPr>
               <a:t>Phan Thị Tường Vi</a:t>
             </a:r>
@@ -5228,8 +5216,8 @@
         </p:nvSpPr>
         <p:spPr>
           <a:xfrm rot="0">
-            <a:off x="1401720" y="1444590"/>
-            <a:ext cx="16029128" cy="2032538"/>
+            <a:off x="1401720" y="1320765"/>
+            <a:ext cx="16029128" cy="2156363"/>
           </a:xfrm>
           <a:prstGeom prst="rect">
             <a:avLst/>
@@ -5251,10 +5239,10 @@
                 <a:solidFill>
                   <a:srgbClr val="FFB9B9"/>
                 </a:solidFill>
-                <a:latin typeface="Canva Sans"/>
-                <a:ea typeface="Canva Sans"/>
-                <a:cs typeface="Canva Sans"/>
-                <a:sym typeface="Canva Sans"/>
+                <a:latin typeface="Times New Roman"/>
+                <a:ea typeface="Times New Roman"/>
+                <a:cs typeface="Times New Roman"/>
+                <a:sym typeface="Times New Roman"/>
               </a:rPr>
               <a:t>Áp dụng Phân tích dữ liệu kinh doanh vào việc Dự báo giá dầu trong tương lai</a:t>
             </a:r>
@@ -6634,8 +6622,8 @@
         </p:nvSpPr>
         <p:spPr>
           <a:xfrm rot="0">
-            <a:off x="3216693" y="995186"/>
-            <a:ext cx="11999462" cy="924543"/>
+            <a:off x="3216693" y="899936"/>
+            <a:ext cx="11999462" cy="1017511"/>
           </a:xfrm>
           <a:prstGeom prst="rect">
             <a:avLst/>
@@ -6657,10 +6645,10 @@
                 <a:solidFill>
                   <a:srgbClr val="FFB9B9"/>
                 </a:solidFill>
-                <a:latin typeface="Bernoru"/>
-                <a:ea typeface="Bernoru"/>
-                <a:cs typeface="Bernoru"/>
-                <a:sym typeface="Bernoru"/>
+                <a:latin typeface="Times New Roman"/>
+                <a:ea typeface="Times New Roman"/>
+                <a:cs typeface="Times New Roman"/>
+                <a:sym typeface="Times New Roman"/>
               </a:rPr>
               <a:t>Phương pháp, kỹ thuật áp dụng</a:t>
             </a:r>
@@ -6675,8 +6663,8 @@
         </p:nvSpPr>
         <p:spPr>
           <a:xfrm rot="0">
-            <a:off x="3119187" y="2792982"/>
-            <a:ext cx="12415916" cy="3702050"/>
+            <a:off x="3119187" y="2726307"/>
+            <a:ext cx="12415916" cy="3768725"/>
           </a:xfrm>
           <a:prstGeom prst="rect">
             <a:avLst/>
@@ -6698,10 +6686,10 @@
                 <a:solidFill>
                   <a:srgbClr val="863434"/>
                 </a:solidFill>
-                <a:latin typeface="Glacial Indifference Bold"/>
-                <a:ea typeface="Glacial Indifference Bold"/>
-                <a:cs typeface="Glacial Indifference Bold"/>
-                <a:sym typeface="Glacial Indifference Bold"/>
+                <a:latin typeface="Times New Roman Bold"/>
+                <a:ea typeface="Times New Roman Bold"/>
+                <a:cs typeface="Times New Roman Bold"/>
+                <a:sym typeface="Times New Roman Bold"/>
               </a:rPr>
               <a:t>3. Mô hình học sâu</a:t>
             </a:r>
@@ -6719,10 +6707,10 @@
                 <a:solidFill>
                   <a:srgbClr val="863434"/>
                 </a:solidFill>
-                <a:latin typeface="Glacial Indifference Bold"/>
-                <a:ea typeface="Glacial Indifference Bold"/>
-                <a:cs typeface="Glacial Indifference Bold"/>
-                <a:sym typeface="Glacial Indifference Bold"/>
+                <a:latin typeface="Times New Roman Bold"/>
+                <a:ea typeface="Times New Roman Bold"/>
+                <a:cs typeface="Times New Roman Bold"/>
+                <a:sym typeface="Times New Roman Bold"/>
               </a:rPr>
               <a:t>LSTM</a:t>
             </a:r>
@@ -6731,10 +6719,10 @@
                 <a:solidFill>
                   <a:srgbClr val="863434"/>
                 </a:solidFill>
-                <a:latin typeface="Glacial Indifference Bold"/>
-                <a:ea typeface="Glacial Indifference Bold"/>
-                <a:cs typeface="Glacial Indifference Bold"/>
-                <a:sym typeface="Glacial Indifference Bold"/>
+                <a:latin typeface="Times New Roman Bold"/>
+                <a:ea typeface="Times New Roman Bold"/>
+                <a:cs typeface="Times New Roman Bold"/>
+                <a:sym typeface="Times New Roman Bold"/>
               </a:rPr>
               <a:t>: </a:t>
             </a:r>
@@ -6743,10 +6731,10 @@
                 <a:solidFill>
                   <a:srgbClr val="863434"/>
                 </a:solidFill>
-                <a:latin typeface="Glacial Indifference"/>
-                <a:ea typeface="Glacial Indifference"/>
-                <a:cs typeface="Glacial Indifference"/>
-                <a:sym typeface="Glacial Indifference"/>
+                <a:latin typeface="Times New Roman"/>
+                <a:ea typeface="Times New Roman"/>
+                <a:cs typeface="Times New Roman"/>
+                <a:sym typeface="Times New Roman"/>
               </a:rPr>
               <a:t>Mạng nơ-ron hồi tiếp có khả năng ghi nhớ thông tin dài hạn, phù hợp với chuỗi thời gian.</a:t>
             </a:r>
@@ -7468,8 +7456,8 @@
           </p:nvSpPr>
           <p:spPr>
             <a:xfrm>
-              <a:off x="0" y="-38100"/>
-              <a:ext cx="3243622" cy="1656099"/>
+              <a:off x="0" y="-76200"/>
+              <a:ext cx="3243622" cy="1694199"/>
             </a:xfrm>
             <a:prstGeom prst="rect">
               <a:avLst/>
@@ -7581,8 +7569,8 @@
           </p:nvSpPr>
           <p:spPr>
             <a:xfrm>
-              <a:off x="0" y="-38100"/>
-              <a:ext cx="3243622" cy="1656099"/>
+              <a:off x="0" y="-76200"/>
+              <a:ext cx="3243622" cy="1694199"/>
             </a:xfrm>
             <a:prstGeom prst="rect">
               <a:avLst/>
@@ -8105,8 +8093,8 @@
         </p:nvSpPr>
         <p:spPr>
           <a:xfrm rot="0">
-            <a:off x="4502587" y="2702185"/>
-            <a:ext cx="9282825" cy="1717654"/>
+            <a:off x="4502587" y="2521210"/>
+            <a:ext cx="9282825" cy="1898629"/>
           </a:xfrm>
           <a:prstGeom prst="rect">
             <a:avLst/>
@@ -8128,10 +8116,10 @@
                 <a:solidFill>
                   <a:srgbClr val="FFB9B9"/>
                 </a:solidFill>
-                <a:latin typeface="Bernoru"/>
-                <a:ea typeface="Bernoru"/>
-                <a:cs typeface="Bernoru"/>
-                <a:sym typeface="Bernoru"/>
+                <a:latin typeface="Times New Roman"/>
+                <a:ea typeface="Times New Roman"/>
+                <a:cs typeface="Times New Roman"/>
+                <a:sym typeface="Times New Roman"/>
               </a:rPr>
               <a:t>Thank You</a:t>
             </a:r>
@@ -9218,8 +9206,8 @@
         </p:nvSpPr>
         <p:spPr>
           <a:xfrm rot="0">
-            <a:off x="6774676" y="1342772"/>
-            <a:ext cx="4738648" cy="1028626"/>
+            <a:off x="6774676" y="1218947"/>
+            <a:ext cx="4738648" cy="1152451"/>
           </a:xfrm>
           <a:prstGeom prst="rect">
             <a:avLst/>
@@ -9241,10 +9229,10 @@
                 <a:solidFill>
                   <a:srgbClr val="FFB9B9"/>
                 </a:solidFill>
-                <a:latin typeface="Canva Sans"/>
-                <a:ea typeface="Canva Sans"/>
-                <a:cs typeface="Canva Sans"/>
-                <a:sym typeface="Canva Sans"/>
+                <a:latin typeface="Times New Roman"/>
+                <a:ea typeface="Times New Roman"/>
+                <a:cs typeface="Times New Roman"/>
+                <a:sym typeface="Times New Roman"/>
               </a:rPr>
               <a:t>Nội dung</a:t>
             </a:r>
@@ -9259,8 +9247,8 @@
         </p:nvSpPr>
         <p:spPr>
           <a:xfrm rot="0">
-            <a:off x="2653838" y="3060918"/>
-            <a:ext cx="14349750" cy="4038749"/>
+            <a:off x="2653838" y="2984718"/>
+            <a:ext cx="14349750" cy="4114949"/>
           </a:xfrm>
           <a:prstGeom prst="rect">
             <a:avLst/>
@@ -9284,10 +9272,10 @@
                 <a:solidFill>
                   <a:srgbClr val="863434"/>
                 </a:solidFill>
-                <a:latin typeface="Canva Sans"/>
-                <a:ea typeface="Canva Sans"/>
-                <a:cs typeface="Canva Sans"/>
-                <a:sym typeface="Canva Sans"/>
+                <a:latin typeface="Times New Roman"/>
+                <a:ea typeface="Times New Roman"/>
+                <a:cs typeface="Times New Roman"/>
+                <a:sym typeface="Times New Roman"/>
               </a:rPr>
               <a:t>Giới thiệu về đề tài</a:t>
             </a:r>
@@ -9305,10 +9293,10 @@
                 <a:solidFill>
                   <a:srgbClr val="863434"/>
                 </a:solidFill>
-                <a:latin typeface="Canva Sans"/>
-                <a:ea typeface="Canva Sans"/>
-                <a:cs typeface="Canva Sans"/>
-                <a:sym typeface="Canva Sans"/>
+                <a:latin typeface="Times New Roman"/>
+                <a:ea typeface="Times New Roman"/>
+                <a:cs typeface="Times New Roman"/>
+                <a:sym typeface="Times New Roman"/>
               </a:rPr>
               <a:t>Giới thiệu chung về bộ dữ liệu</a:t>
             </a:r>
@@ -9326,10 +9314,10 @@
                 <a:solidFill>
                   <a:srgbClr val="863434"/>
                 </a:solidFill>
-                <a:latin typeface="Canva Sans"/>
-                <a:ea typeface="Canva Sans"/>
-                <a:cs typeface="Canva Sans"/>
-                <a:sym typeface="Canva Sans"/>
+                <a:latin typeface="Times New Roman"/>
+                <a:ea typeface="Times New Roman"/>
+                <a:cs typeface="Times New Roman"/>
+                <a:sym typeface="Times New Roman"/>
               </a:rPr>
               <a:t>Giới thiệu chung về bài toán, các hướng tiếp cận</a:t>
             </a:r>
@@ -9347,10 +9335,10 @@
                 <a:solidFill>
                   <a:srgbClr val="863434"/>
                 </a:solidFill>
-                <a:latin typeface="Canva Sans"/>
-                <a:ea typeface="Canva Sans"/>
-                <a:cs typeface="Canva Sans"/>
-                <a:sym typeface="Canva Sans"/>
+                <a:latin typeface="Times New Roman"/>
+                <a:ea typeface="Times New Roman"/>
+                <a:cs typeface="Times New Roman"/>
+                <a:sym typeface="Times New Roman"/>
               </a:rPr>
               <a:t>Giới thiệu chung về phương pháp, kỹ thuật áp dụng</a:t>
             </a:r>
@@ -10065,8 +10053,8 @@
           </p:nvSpPr>
           <p:spPr>
             <a:xfrm>
-              <a:off x="0" y="-38100"/>
-              <a:ext cx="3243622" cy="1656099"/>
+              <a:off x="0" y="-76200"/>
+              <a:ext cx="3243622" cy="1694199"/>
             </a:xfrm>
             <a:prstGeom prst="rect">
               <a:avLst/>
@@ -10178,8 +10166,8 @@
           </p:nvSpPr>
           <p:spPr>
             <a:xfrm>
-              <a:off x="0" y="-38100"/>
-              <a:ext cx="3243622" cy="1656099"/>
+              <a:off x="0" y="-76200"/>
+              <a:ext cx="3243622" cy="1694199"/>
             </a:xfrm>
             <a:prstGeom prst="rect">
               <a:avLst/>
@@ -10677,8 +10665,8 @@
         </p:nvSpPr>
         <p:spPr>
           <a:xfrm rot="0">
-            <a:off x="5496556" y="895350"/>
-            <a:ext cx="7393673" cy="1047676"/>
+            <a:off x="5496556" y="790575"/>
+            <a:ext cx="7393673" cy="1152451"/>
           </a:xfrm>
           <a:prstGeom prst="rect">
             <a:avLst/>
@@ -10700,10 +10688,10 @@
                 <a:solidFill>
                   <a:srgbClr val="FFB9B9"/>
                 </a:solidFill>
-                <a:latin typeface="Bernoru"/>
-                <a:ea typeface="Bernoru"/>
-                <a:cs typeface="Bernoru"/>
-                <a:sym typeface="Bernoru"/>
+                <a:latin typeface="Times New Roman"/>
+                <a:ea typeface="Times New Roman"/>
+                <a:cs typeface="Times New Roman"/>
+                <a:sym typeface="Times New Roman"/>
               </a:rPr>
               <a:t>Đề tài</a:t>
             </a:r>
@@ -10718,8 +10706,8 @@
         </p:nvSpPr>
         <p:spPr>
           <a:xfrm rot="0">
-            <a:off x="3377022" y="2616001"/>
-            <a:ext cx="11632741" cy="4930775"/>
+            <a:off x="3377022" y="2539801"/>
+            <a:ext cx="11632741" cy="4387850"/>
           </a:xfrm>
           <a:prstGeom prst="rect">
             <a:avLst/>
@@ -10741,12 +10729,12 @@
                 <a:solidFill>
                   <a:srgbClr val="863434"/>
                 </a:solidFill>
-                <a:latin typeface="Canva Sans"/>
-                <a:ea typeface="Canva Sans"/>
-                <a:cs typeface="Canva Sans"/>
-                <a:sym typeface="Canva Sans"/>
+                <a:latin typeface="Times New Roman"/>
+                <a:ea typeface="Times New Roman"/>
+                <a:cs typeface="Times New Roman"/>
+                <a:sym typeface="Times New Roman"/>
               </a:rPr>
-              <a:t>Đề tài nghiên cứu áp dụng các kỹ thuật phân tích dữ liệu và mô hình học máy, học sâu, chuỗi thời gian để dự báo giá dầu trong tương lai. Các mô hình sẽ được thử nghiệm với các đặc trưng khác nhau (ví dụ: chỉ sử dụng giá đóng cửa, hoặc kết hợp thêm các yếu tố như giá mở cửa, giá cao nhất, giá thấp nhất,…), để xác định mô hình nào hoạt động tốt nhất trong việc dự báo biến động giá dầu</a:t>
+              <a:t>Đề tài nghiên cứu áp dụng các kỹ thuật phân tích dữ liệu và mô hình học máy, học sâu, chuỗi thời gian để dự báo giá dầu trong tương lai. Các mô hình sẽ được thử nghiệm với các đặc trưng khác nhau (ví dụ: chỉ sử dụng giá đóng cửa, hoặc kết hợp thêm các yếu tố như giá mở cửa, giá cao nhất, giá thấp nhất,…), để xác định mô hình nào hoạt động tốt nhất trong việc dự báo biến động giá dầu.</a:t>
             </a:r>
           </a:p>
         </p:txBody>
@@ -11455,8 +11443,8 @@
           </p:nvSpPr>
           <p:spPr>
             <a:xfrm>
-              <a:off x="0" y="-38100"/>
-              <a:ext cx="4243002" cy="1921817"/>
+              <a:off x="0" y="-76200"/>
+              <a:ext cx="4243002" cy="1959917"/>
             </a:xfrm>
             <a:prstGeom prst="rect">
               <a:avLst/>
@@ -11954,8 +11942,8 @@
         </p:nvSpPr>
         <p:spPr>
           <a:xfrm rot="0">
-            <a:off x="5277220" y="397609"/>
-            <a:ext cx="7393673" cy="1047676"/>
+            <a:off x="5277220" y="292834"/>
+            <a:ext cx="7393673" cy="1152451"/>
           </a:xfrm>
           <a:prstGeom prst="rect">
             <a:avLst/>
@@ -11977,10 +11965,10 @@
                 <a:solidFill>
                   <a:srgbClr val="FFB9B9"/>
                 </a:solidFill>
-                <a:latin typeface="Bernoru"/>
-                <a:ea typeface="Bernoru"/>
-                <a:cs typeface="Bernoru"/>
-                <a:sym typeface="Bernoru"/>
+                <a:latin typeface="Times New Roman"/>
+                <a:ea typeface="Times New Roman"/>
+                <a:cs typeface="Times New Roman"/>
+                <a:sym typeface="Times New Roman"/>
               </a:rPr>
               <a:t>Dataset</a:t>
             </a:r>
@@ -11995,8 +11983,8 @@
         </p:nvSpPr>
         <p:spPr>
           <a:xfrm rot="0">
-            <a:off x="1965657" y="2287225"/>
-            <a:ext cx="14655871" cy="9883775"/>
+            <a:off x="1965657" y="2220550"/>
+            <a:ext cx="14655871" cy="10507310"/>
           </a:xfrm>
           <a:prstGeom prst="rect">
             <a:avLst/>
@@ -12010,30 +11998,30 @@
           <a:p>
             <a:pPr algn="just">
               <a:lnSpc>
-                <a:spcPts val="4900"/>
+                <a:spcPts val="4620"/>
               </a:lnSpc>
             </a:pPr>
             <a:r>
-              <a:rPr lang="en-US" sz="3500" b="true">
+              <a:rPr lang="en-US" sz="3300" b="true">
                 <a:solidFill>
                   <a:srgbClr val="863434"/>
                 </a:solidFill>
-                <a:latin typeface="Canva Sans Bold"/>
-                <a:ea typeface="Canva Sans Bold"/>
-                <a:cs typeface="Canva Sans Bold"/>
-                <a:sym typeface="Canva Sans Bold"/>
+                <a:latin typeface="Times New Roman Bold"/>
+                <a:ea typeface="Times New Roman Bold"/>
+                <a:cs typeface="Times New Roman Bold"/>
+                <a:sym typeface="Times New Roman Bold"/>
               </a:rPr>
               <a:t>Tên bộ dữ liệu: </a:t>
             </a:r>
             <a:r>
-              <a:rPr lang="en-US" sz="3500">
+              <a:rPr lang="en-US" sz="3300">
                 <a:solidFill>
                   <a:srgbClr val="863434"/>
                 </a:solidFill>
-                <a:latin typeface="Canva Sans"/>
-                <a:ea typeface="Canva Sans"/>
-                <a:cs typeface="Canva Sans"/>
-                <a:sym typeface="Canva Sans"/>
+                <a:latin typeface="Times New Roman"/>
+                <a:ea typeface="Times New Roman"/>
+                <a:cs typeface="Times New Roman"/>
+                <a:sym typeface="Times New Roman"/>
               </a:rPr>
               <a:t>Oil, Gas &amp; Other Fuels Futures Data</a:t>
             </a:r>
@@ -12041,30 +12029,30 @@
           <a:p>
             <a:pPr algn="just">
               <a:lnSpc>
-                <a:spcPts val="4900"/>
+                <a:spcPts val="4620"/>
               </a:lnSpc>
             </a:pPr>
             <a:r>
-              <a:rPr lang="en-US" sz="3500" b="true">
+              <a:rPr lang="en-US" sz="3300" b="true">
                 <a:solidFill>
                   <a:srgbClr val="863434"/>
                 </a:solidFill>
-                <a:latin typeface="Canva Sans Bold"/>
-                <a:ea typeface="Canva Sans Bold"/>
-                <a:cs typeface="Canva Sans Bold"/>
-                <a:sym typeface="Canva Sans Bold"/>
+                <a:latin typeface="Times New Roman Bold"/>
+                <a:ea typeface="Times New Roman Bold"/>
+                <a:cs typeface="Times New Roman Bold"/>
+                <a:sym typeface="Times New Roman Bold"/>
               </a:rPr>
               <a:t>Cộng tác viên:</a:t>
             </a:r>
             <a:r>
-              <a:rPr lang="en-US" sz="3500">
+              <a:rPr lang="en-US" sz="3300">
                 <a:solidFill>
                   <a:srgbClr val="863434"/>
                 </a:solidFill>
-                <a:latin typeface="Canva Sans"/>
-                <a:ea typeface="Canva Sans"/>
-                <a:cs typeface="Canva Sans"/>
-                <a:sym typeface="Canva Sans"/>
+                <a:latin typeface="Times New Roman"/>
+                <a:ea typeface="Times New Roman"/>
+                <a:cs typeface="Times New Roman"/>
+                <a:sym typeface="Times New Roman"/>
               </a:rPr>
               <a:t> Guillem SD</a:t>
             </a:r>
@@ -12072,30 +12060,30 @@
           <a:p>
             <a:pPr algn="just">
               <a:lnSpc>
-                <a:spcPts val="4900"/>
+                <a:spcPts val="4620"/>
               </a:lnSpc>
             </a:pPr>
             <a:r>
-              <a:rPr lang="en-US" sz="3500" b="true">
+              <a:rPr lang="en-US" sz="3300" b="true">
                 <a:solidFill>
                   <a:srgbClr val="863434"/>
                 </a:solidFill>
-                <a:latin typeface="Canva Sans Bold"/>
-                <a:ea typeface="Canva Sans Bold"/>
-                <a:cs typeface="Canva Sans Bold"/>
-                <a:sym typeface="Canva Sans Bold"/>
+                <a:latin typeface="Times New Roman Bold"/>
+                <a:ea typeface="Times New Roman Bold"/>
+                <a:cs typeface="Times New Roman Bold"/>
+                <a:sym typeface="Times New Roman Bold"/>
               </a:rPr>
               <a:t>Nguồn: </a:t>
             </a:r>
             <a:r>
-              <a:rPr lang="en-US" sz="3500">
+              <a:rPr lang="en-US" sz="3300">
                 <a:solidFill>
                   <a:srgbClr val="863434"/>
                 </a:solidFill>
-                <a:latin typeface="Canva Sans"/>
-                <a:ea typeface="Canva Sans"/>
-                <a:cs typeface="Canva Sans"/>
-                <a:sym typeface="Canva Sans"/>
+                <a:latin typeface="Times New Roman"/>
+                <a:ea typeface="Times New Roman"/>
+                <a:cs typeface="Times New Roman"/>
+                <a:sym typeface="Times New Roman"/>
               </a:rPr>
               <a:t>Yahoo Finance</a:t>
             </a:r>
@@ -12103,30 +12091,30 @@
           <a:p>
             <a:pPr algn="just">
               <a:lnSpc>
-                <a:spcPts val="4900"/>
+                <a:spcPts val="4620"/>
               </a:lnSpc>
             </a:pPr>
             <a:r>
-              <a:rPr lang="en-US" sz="3500" b="true">
+              <a:rPr lang="en-US" sz="3300" b="true">
                 <a:solidFill>
                   <a:srgbClr val="863434"/>
                 </a:solidFill>
-                <a:latin typeface="Canva Sans Bold"/>
-                <a:ea typeface="Canva Sans Bold"/>
-                <a:cs typeface="Canva Sans Bold"/>
-                <a:sym typeface="Canva Sans Bold"/>
+                <a:latin typeface="Times New Roman Bold"/>
+                <a:ea typeface="Times New Roman Bold"/>
+                <a:cs typeface="Times New Roman Bold"/>
+                <a:sym typeface="Times New Roman Bold"/>
               </a:rPr>
               <a:t>Thời gian: </a:t>
             </a:r>
             <a:r>
-              <a:rPr lang="en-US" sz="3500">
+              <a:rPr lang="en-US" sz="3300">
                 <a:solidFill>
                   <a:srgbClr val="863434"/>
                 </a:solidFill>
-                <a:latin typeface="Canva Sans"/>
-                <a:ea typeface="Canva Sans"/>
-                <a:cs typeface="Canva Sans"/>
-                <a:sym typeface="Canva Sans"/>
+                <a:latin typeface="Times New Roman"/>
+                <a:ea typeface="Times New Roman"/>
+                <a:cs typeface="Times New Roman"/>
+                <a:sym typeface="Times New Roman"/>
               </a:rPr>
               <a:t>23/08/2000 – 24/06/2024</a:t>
             </a:r>
@@ -12134,30 +12122,49 @@
           <a:p>
             <a:pPr algn="just">
               <a:lnSpc>
-                <a:spcPts val="4900"/>
+                <a:spcPts val="4620"/>
               </a:lnSpc>
             </a:pPr>
             <a:r>
-              <a:rPr lang="en-US" sz="3500" b="true">
+              <a:rPr lang="en-US" sz="3300">
                 <a:solidFill>
                   <a:srgbClr val="863434"/>
                 </a:solidFill>
-                <a:latin typeface="Canva Sans Bold"/>
-                <a:ea typeface="Canva Sans Bold"/>
-                <a:cs typeface="Canva Sans Bold"/>
-                <a:sym typeface="Canva Sans Bold"/>
+                <a:latin typeface="Times New Roman"/>
+                <a:ea typeface="Times New Roman"/>
+                <a:cs typeface="Times New Roman"/>
+                <a:sym typeface="Times New Roman"/>
+              </a:rPr>
+              <a:t>Bao gồm 8 cột và 28075 dòng dữ liệu.</a:t>
+            </a:r>
+          </a:p>
+          <a:p>
+            <a:pPr algn="just">
+              <a:lnSpc>
+                <a:spcPts val="4620"/>
+              </a:lnSpc>
+            </a:pPr>
+            <a:r>
+              <a:rPr lang="en-US" sz="3300" b="true">
+                <a:solidFill>
+                  <a:srgbClr val="863434"/>
+                </a:solidFill>
+                <a:latin typeface="Times New Roman Bold"/>
+                <a:ea typeface="Times New Roman Bold"/>
+                <a:cs typeface="Times New Roman Bold"/>
+                <a:sym typeface="Times New Roman Bold"/>
               </a:rPr>
               <a:t>Tổng quan: </a:t>
             </a:r>
             <a:r>
-              <a:rPr lang="en-US" sz="3500">
+              <a:rPr lang="en-US" sz="3300">
                 <a:solidFill>
                   <a:srgbClr val="863434"/>
                 </a:solidFill>
-                <a:latin typeface="Canva Sans"/>
-                <a:ea typeface="Canva Sans"/>
-                <a:cs typeface="Canva Sans"/>
-                <a:sym typeface="Canva Sans"/>
+                <a:latin typeface="Times New Roman"/>
+                <a:ea typeface="Times New Roman"/>
+                <a:cs typeface="Times New Roman"/>
+                <a:sym typeface="Times New Roman"/>
               </a:rPr>
               <a:t>Tập dữ liệu này cung cấp thông tin toàn diện và cập nhật mới về hợp đồng tương lai liên quan đến dầu, khí đốt và các loại nhiên liệu khác. Hợp đồng tương lai là các hợp đồng tài chính bắt buộc người mua phải mua và người bán phải bán một lượng nhiên liệu cụ thể với mức giá được xác định trước vào một ngày trong tương lai.</a:t>
             </a:r>
@@ -12165,42 +12172,56 @@
           <a:p>
             <a:pPr algn="just">
               <a:lnSpc>
-                <a:spcPts val="4900"/>
+                <a:spcPts val="4620"/>
               </a:lnSpc>
             </a:pPr>
           </a:p>
           <a:p>
             <a:pPr algn="just">
               <a:lnSpc>
-                <a:spcPts val="4900"/>
+                <a:spcPts val="4620"/>
               </a:lnSpc>
             </a:pPr>
           </a:p>
           <a:p>
             <a:pPr algn="just">
               <a:lnSpc>
-                <a:spcPts val="4900"/>
+                <a:spcPts val="4620"/>
               </a:lnSpc>
             </a:pPr>
           </a:p>
           <a:p>
             <a:pPr algn="just">
               <a:lnSpc>
-                <a:spcPts val="4900"/>
+                <a:spcPts val="4620"/>
               </a:lnSpc>
             </a:pPr>
           </a:p>
           <a:p>
             <a:pPr algn="just">
               <a:lnSpc>
-                <a:spcPts val="4900"/>
+                <a:spcPts val="4620"/>
               </a:lnSpc>
             </a:pPr>
           </a:p>
           <a:p>
             <a:pPr algn="just">
               <a:lnSpc>
-                <a:spcPts val="4900"/>
+                <a:spcPts val="4620"/>
+              </a:lnSpc>
+            </a:pPr>
+          </a:p>
+          <a:p>
+            <a:pPr algn="just">
+              <a:lnSpc>
+                <a:spcPts val="4620"/>
+              </a:lnSpc>
+            </a:pPr>
+          </a:p>
+          <a:p>
+            <a:pPr algn="just">
+              <a:lnSpc>
+                <a:spcPts val="4620"/>
               </a:lnSpc>
             </a:pPr>
           </a:p>
@@ -12895,8 +12916,8 @@
           </p:nvSpPr>
           <p:spPr>
             <a:xfrm>
-              <a:off x="0" y="-38100"/>
-              <a:ext cx="3954324" cy="1904222"/>
+              <a:off x="0" y="-76200"/>
+              <a:ext cx="3954324" cy="1942322"/>
             </a:xfrm>
             <a:prstGeom prst="rect">
               <a:avLst/>
@@ -13023,8 +13044,8 @@
           </p:nvSpPr>
           <p:spPr>
             <a:xfrm>
-              <a:off x="0" y="-38100"/>
-              <a:ext cx="4190518" cy="1886760"/>
+              <a:off x="0" y="-76200"/>
+              <a:ext cx="4190518" cy="1924860"/>
             </a:xfrm>
             <a:prstGeom prst="rect">
               <a:avLst/>
@@ -13522,8 +13543,8 @@
         </p:nvSpPr>
         <p:spPr>
           <a:xfrm rot="0">
-            <a:off x="4707846" y="545992"/>
-            <a:ext cx="9282825" cy="1047676"/>
+            <a:off x="4707846" y="441217"/>
+            <a:ext cx="9282825" cy="1152451"/>
           </a:xfrm>
           <a:prstGeom prst="rect">
             <a:avLst/>
@@ -13545,10 +13566,10 @@
                 <a:solidFill>
                   <a:srgbClr val="FFB9B9"/>
                 </a:solidFill>
-                <a:latin typeface="Bernoru"/>
-                <a:ea typeface="Bernoru"/>
-                <a:cs typeface="Bernoru"/>
-                <a:sym typeface="Bernoru"/>
+                <a:latin typeface="Times New Roman"/>
+                <a:ea typeface="Times New Roman"/>
+                <a:cs typeface="Times New Roman"/>
+                <a:sym typeface="Times New Roman"/>
               </a:rPr>
               <a:t>Dataset</a:t>
             </a:r>
@@ -13563,8 +13584,8 @@
         </p:nvSpPr>
         <p:spPr>
           <a:xfrm rot="0">
-            <a:off x="2120138" y="1903551"/>
-            <a:ext cx="15313847" cy="7182108"/>
+            <a:off x="2120138" y="1836876"/>
+            <a:ext cx="15313847" cy="7248783"/>
           </a:xfrm>
           <a:prstGeom prst="rect">
             <a:avLst/>
@@ -13586,22 +13607,22 @@
                 <a:solidFill>
                   <a:srgbClr val="863434"/>
                 </a:solidFill>
-                <a:latin typeface="Canva Sans Bold"/>
-                <a:ea typeface="Canva Sans Bold"/>
-                <a:cs typeface="Canva Sans Bold"/>
-                <a:sym typeface="Canva Sans Bold"/>
+                <a:latin typeface="Times New Roman Bold"/>
+                <a:ea typeface="Times New Roman Bold"/>
+                <a:cs typeface="Times New Roman Bold"/>
+                <a:sym typeface="Times New Roman Bold"/>
               </a:rPr>
-              <a:t>Date (Ngày): </a:t>
+              <a:t>. Date (Ngày): </a:t>
             </a:r>
             <a:r>
               <a:rPr lang="en-US" sz="3400">
                 <a:solidFill>
                   <a:srgbClr val="863434"/>
                 </a:solidFill>
-                <a:latin typeface="Canva Sans"/>
-                <a:ea typeface="Canva Sans"/>
-                <a:cs typeface="Canva Sans"/>
-                <a:sym typeface="Canva Sans"/>
+                <a:latin typeface="Times New Roman"/>
+                <a:ea typeface="Times New Roman"/>
+                <a:cs typeface="Times New Roman"/>
+                <a:sym typeface="Times New Roman"/>
               </a:rPr>
               <a:t>Ngày dữ liệu được ghi nhận.</a:t>
             </a:r>
@@ -13617,10 +13638,10 @@
                 <a:solidFill>
                   <a:srgbClr val="863434"/>
                 </a:solidFill>
-                <a:latin typeface="Canva Sans Bold"/>
-                <a:ea typeface="Canva Sans Bold"/>
-                <a:cs typeface="Canva Sans Bold"/>
-                <a:sym typeface="Canva Sans Bold"/>
+                <a:latin typeface="Times New Roman Bold"/>
+                <a:ea typeface="Times New Roman Bold"/>
+                <a:cs typeface="Times New Roman Bold"/>
+                <a:sym typeface="Times New Roman Bold"/>
               </a:rPr>
               <a:t>· Open (Giá mở cửa): </a:t>
             </a:r>
@@ -13629,10 +13650,10 @@
                 <a:solidFill>
                   <a:srgbClr val="863434"/>
                 </a:solidFill>
-                <a:latin typeface="Canva Sans"/>
-                <a:ea typeface="Canva Sans"/>
-                <a:cs typeface="Canva Sans"/>
-                <a:sym typeface="Canva Sans"/>
+                <a:latin typeface="Times New Roman"/>
+                <a:ea typeface="Times New Roman"/>
+                <a:cs typeface="Times New Roman"/>
+                <a:sym typeface="Times New Roman"/>
               </a:rPr>
               <a:t>Giá mở cửa của thị trường trong ngày.</a:t>
             </a:r>
@@ -13648,10 +13669,10 @@
                 <a:solidFill>
                   <a:srgbClr val="863434"/>
                 </a:solidFill>
-                <a:latin typeface="Canva Sans Bold"/>
-                <a:ea typeface="Canva Sans Bold"/>
-                <a:cs typeface="Canva Sans Bold"/>
-                <a:sym typeface="Canva Sans Bold"/>
+                <a:latin typeface="Times New Roman Bold"/>
+                <a:ea typeface="Times New Roman Bold"/>
+                <a:cs typeface="Times New Roman Bold"/>
+                <a:sym typeface="Times New Roman Bold"/>
               </a:rPr>
               <a:t>· High (Giá cao nhất): </a:t>
             </a:r>
@@ -13660,10 +13681,10 @@
                 <a:solidFill>
                   <a:srgbClr val="863434"/>
                 </a:solidFill>
-                <a:latin typeface="Canva Sans"/>
-                <a:ea typeface="Canva Sans"/>
-                <a:cs typeface="Canva Sans"/>
-                <a:sym typeface="Canva Sans"/>
+                <a:latin typeface="Times New Roman"/>
+                <a:ea typeface="Times New Roman"/>
+                <a:cs typeface="Times New Roman"/>
+                <a:sym typeface="Times New Roman"/>
               </a:rPr>
               <a:t>Mức giá cao nhất trong phiên giao dịch.</a:t>
             </a:r>
@@ -13679,10 +13700,10 @@
                 <a:solidFill>
                   <a:srgbClr val="863434"/>
                 </a:solidFill>
-                <a:latin typeface="Canva Sans Bold"/>
-                <a:ea typeface="Canva Sans Bold"/>
-                <a:cs typeface="Canva Sans Bold"/>
-                <a:sym typeface="Canva Sans Bold"/>
+                <a:latin typeface="Times New Roman Bold"/>
+                <a:ea typeface="Times New Roman Bold"/>
+                <a:cs typeface="Times New Roman Bold"/>
+                <a:sym typeface="Times New Roman Bold"/>
               </a:rPr>
               <a:t>· Low (Giá thấp nhất): </a:t>
             </a:r>
@@ -13691,10 +13712,10 @@
                 <a:solidFill>
                   <a:srgbClr val="863434"/>
                 </a:solidFill>
-                <a:latin typeface="Canva Sans"/>
-                <a:ea typeface="Canva Sans"/>
-                <a:cs typeface="Canva Sans"/>
-                <a:sym typeface="Canva Sans"/>
+                <a:latin typeface="Times New Roman"/>
+                <a:ea typeface="Times New Roman"/>
+                <a:cs typeface="Times New Roman"/>
+                <a:sym typeface="Times New Roman"/>
               </a:rPr>
               <a:t>Mức giá thấp nhất trong ngày giao dịch.</a:t>
             </a:r>
@@ -13710,10 +13731,10 @@
                 <a:solidFill>
                   <a:srgbClr val="863434"/>
                 </a:solidFill>
-                <a:latin typeface="Canva Sans Bold"/>
-                <a:ea typeface="Canva Sans Bold"/>
-                <a:cs typeface="Canva Sans Bold"/>
-                <a:sym typeface="Canva Sans Bold"/>
+                <a:latin typeface="Times New Roman Bold"/>
+                <a:ea typeface="Times New Roman Bold"/>
+                <a:cs typeface="Times New Roman Bold"/>
+                <a:sym typeface="Times New Roman Bold"/>
               </a:rPr>
               <a:t>· Close (Giá đóng cửa): </a:t>
             </a:r>
@@ -13722,10 +13743,10 @@
                 <a:solidFill>
                   <a:srgbClr val="863434"/>
                 </a:solidFill>
-                <a:latin typeface="Canva Sans"/>
-                <a:ea typeface="Canva Sans"/>
-                <a:cs typeface="Canva Sans"/>
-                <a:sym typeface="Canva Sans"/>
+                <a:latin typeface="Times New Roman"/>
+                <a:ea typeface="Times New Roman"/>
+                <a:cs typeface="Times New Roman"/>
+                <a:sym typeface="Times New Roman"/>
               </a:rPr>
               <a:t>Giá thị trường khi kết thúc phiên giao dịch.</a:t>
             </a:r>
@@ -13741,10 +13762,10 @@
                 <a:solidFill>
                   <a:srgbClr val="863434"/>
                 </a:solidFill>
-                <a:latin typeface="Canva Sans Bold"/>
-                <a:ea typeface="Canva Sans Bold"/>
-                <a:cs typeface="Canva Sans Bold"/>
-                <a:sym typeface="Canva Sans Bold"/>
+                <a:latin typeface="Times New Roman Bold"/>
+                <a:ea typeface="Times New Roman Bold"/>
+                <a:cs typeface="Times New Roman Bold"/>
+                <a:sym typeface="Times New Roman Bold"/>
               </a:rPr>
               <a:t>· Volume (Khối lượng giao dịch): </a:t>
             </a:r>
@@ -13753,10 +13774,10 @@
                 <a:solidFill>
                   <a:srgbClr val="863434"/>
                 </a:solidFill>
-                <a:latin typeface="Canva Sans"/>
-                <a:ea typeface="Canva Sans"/>
-                <a:cs typeface="Canva Sans"/>
-                <a:sym typeface="Canva Sans"/>
+                <a:latin typeface="Times New Roman"/>
+                <a:ea typeface="Times New Roman"/>
+                <a:cs typeface="Times New Roman"/>
+                <a:sym typeface="Times New Roman"/>
               </a:rPr>
               <a:t>Số lượng hợp đồng được trao đổi trong phiên giao dịch.</a:t>
             </a:r>
@@ -13772,10 +13793,10 @@
                 <a:solidFill>
                   <a:srgbClr val="863434"/>
                 </a:solidFill>
-                <a:latin typeface="Canva Sans Bold"/>
-                <a:ea typeface="Canva Sans Bold"/>
-                <a:cs typeface="Canva Sans Bold"/>
-                <a:sym typeface="Canva Sans Bold"/>
+                <a:latin typeface="Times New Roman Bold"/>
+                <a:ea typeface="Times New Roman Bold"/>
+                <a:cs typeface="Times New Roman Bold"/>
+                <a:sym typeface="Times New Roman Bold"/>
               </a:rPr>
               <a:t>· Ticker (Mã giao dịch): </a:t>
             </a:r>
@@ -13784,10 +13805,10 @@
                 <a:solidFill>
                   <a:srgbClr val="863434"/>
                 </a:solidFill>
-                <a:latin typeface="Canva Sans"/>
-                <a:ea typeface="Canva Sans"/>
-                <a:cs typeface="Canva Sans"/>
-                <a:sym typeface="Canva Sans"/>
+                <a:latin typeface="Times New Roman"/>
+                <a:ea typeface="Times New Roman"/>
+                <a:cs typeface="Times New Roman"/>
+                <a:sym typeface="Times New Roman"/>
               </a:rPr>
               <a:t>Ký hiệu niêm yết duy nhất của hợp đồng tương lai trên thị trường.</a:t>
             </a:r>
@@ -13803,10 +13824,10 @@
                 <a:solidFill>
                   <a:srgbClr val="863434"/>
                 </a:solidFill>
-                <a:latin typeface="Canva Sans Bold"/>
-                <a:ea typeface="Canva Sans Bold"/>
-                <a:cs typeface="Canva Sans Bold"/>
-                <a:sym typeface="Canva Sans Bold"/>
+                <a:latin typeface="Times New Roman Bold"/>
+                <a:ea typeface="Times New Roman Bold"/>
+                <a:cs typeface="Times New Roman Bold"/>
+                <a:sym typeface="Times New Roman Bold"/>
               </a:rPr>
               <a:t>· Commodity (Hàng hóa):</a:t>
             </a:r>
@@ -13815,12 +13836,12 @@
                 <a:solidFill>
                   <a:srgbClr val="863434"/>
                 </a:solidFill>
-                <a:latin typeface="Canva Sans"/>
-                <a:ea typeface="Canva Sans"/>
-                <a:cs typeface="Canva Sans"/>
-                <a:sym typeface="Canva Sans"/>
+                <a:latin typeface="Times New Roman"/>
+                <a:ea typeface="Times New Roman"/>
+                <a:cs typeface="Times New Roman"/>
+                <a:sym typeface="Times New Roman"/>
               </a:rPr>
-              <a:t> Loại nhiên liệu mà hợp đồng tương lai đề cập đến (ví dụ: dầu thô, khí tự nhiên)</a:t>
+              <a:t> Loại nhiên liệu mà hợp đồng tương lai đề cập đến (ví dụ: dầu thô, khí tự nhiên).</a:t>
             </a:r>
           </a:p>
           <a:p>
@@ -14526,8 +14547,8 @@
           </p:nvSpPr>
           <p:spPr>
             <a:xfrm>
-              <a:off x="0" y="-38100"/>
-              <a:ext cx="3243622" cy="1656099"/>
+              <a:off x="0" y="-76200"/>
+              <a:ext cx="3243622" cy="1694199"/>
             </a:xfrm>
             <a:prstGeom prst="rect">
               <a:avLst/>
@@ -14639,8 +14660,8 @@
           </p:nvSpPr>
           <p:spPr>
             <a:xfrm>
-              <a:off x="0" y="-38100"/>
-              <a:ext cx="3243622" cy="1656099"/>
+              <a:off x="0" y="-76200"/>
+              <a:ext cx="3243622" cy="1694199"/>
             </a:xfrm>
             <a:prstGeom prst="rect">
               <a:avLst/>
@@ -15138,8 +15159,8 @@
         </p:nvSpPr>
         <p:spPr>
           <a:xfrm rot="0">
-            <a:off x="3085005" y="833456"/>
-            <a:ext cx="11875366" cy="1047676"/>
+            <a:off x="3085005" y="728681"/>
+            <a:ext cx="11875366" cy="1152451"/>
           </a:xfrm>
           <a:prstGeom prst="rect">
             <a:avLst/>
@@ -15161,10 +15182,10 @@
                 <a:solidFill>
                   <a:srgbClr val="FFB9B9"/>
                 </a:solidFill>
-                <a:latin typeface="Bernoru"/>
-                <a:ea typeface="Bernoru"/>
-                <a:cs typeface="Bernoru"/>
-                <a:sym typeface="Bernoru"/>
+                <a:latin typeface="Times New Roman"/>
+                <a:ea typeface="Times New Roman"/>
+                <a:cs typeface="Times New Roman"/>
+                <a:sym typeface="Times New Roman"/>
               </a:rPr>
               <a:t>Bài toán</a:t>
             </a:r>
@@ -15179,8 +15200,8 @@
         </p:nvSpPr>
         <p:spPr>
           <a:xfrm rot="0">
-            <a:off x="3327630" y="2458838"/>
-            <a:ext cx="11632741" cy="6169025"/>
+            <a:off x="3327630" y="2382638"/>
+            <a:ext cx="11632741" cy="5626100"/>
           </a:xfrm>
           <a:prstGeom prst="rect">
             <a:avLst/>
@@ -15192,38 +15213,26 @@
           </a:bodyPr>
           <a:lstStyle/>
           <a:p>
-            <a:pPr algn="ctr">
+            <a:pPr algn="just">
               <a:lnSpc>
                 <a:spcPts val="4900"/>
               </a:lnSpc>
             </a:pPr>
             <a:r>
-              <a:rPr lang="en-US" sz="3500" b="true">
-                <a:solidFill>
-                  <a:srgbClr val="863434"/>
-                </a:solidFill>
-                <a:latin typeface="Canva Sans Bold"/>
-                <a:ea typeface="Canva Sans Bold"/>
-                <a:cs typeface="Canva Sans Bold"/>
-                <a:sym typeface="Canva Sans Bold"/>
-              </a:rPr>
-              <a:t>Dự báo giá tương lai của dầu, khí đốt và các loại nhiên liệu khác</a:t>
-            </a:r>
-            <a:r>
               <a:rPr lang="en-US" sz="3500">
                 <a:solidFill>
                   <a:srgbClr val="863434"/>
                 </a:solidFill>
-                <a:latin typeface="Canva Sans"/>
-                <a:ea typeface="Canva Sans"/>
-                <a:cs typeface="Canva Sans"/>
-                <a:sym typeface="Canva Sans"/>
+                <a:latin typeface="Times New Roman"/>
+                <a:ea typeface="Times New Roman"/>
+                <a:cs typeface="Times New Roman"/>
+                <a:sym typeface="Times New Roman"/>
               </a:rPr>
-              <a:t> là một bài toán quan trọng trong lĩnh vực tài chính và năng lượng. Giá cả của các loại nhiên liệu này biến động theo thời gian do ảnh hưởng của các yếu tố kinh tế, chính trị, và môi trường. Việc dự báo chính xác giá nhiên liệu giúp các nhà đầu tư, doanh nghiệp, và cơ quan quản lý có thể đưa ra quyết định phù hợp về đầu tư, phòng ngừa rủi ro, và tối ưu hóa lợi nhuận.</a:t>
+              <a:t>Dự báo giá tương lai của dầu, khí đốt và các loại nhiên liệu khác là một bài toán quan trọng trong lĩnh vực tài chính và năng lượng. Giá cả của các loại nhiên liệu này biến động theo thời gian do ảnh hưởng của các yếu tố kinh tế, chính trị, và môi trường. Việc dự báo chính xác giá nhiên liệu giúp các nhà đầu tư, doanh nghiệp, và cơ quan quản lý có thể đưa ra quyết định phù hợp về đầu tư, phòng ngừa rủi ro, và tối ưu hóa lợi nhuận.</a:t>
             </a:r>
           </a:p>
           <a:p>
-            <a:pPr algn="ctr">
+            <a:pPr algn="just">
               <a:lnSpc>
                 <a:spcPts val="4900"/>
               </a:lnSpc>
@@ -15920,8 +15929,8 @@
           </p:nvSpPr>
           <p:spPr>
             <a:xfrm>
-              <a:off x="0" y="-38100"/>
-              <a:ext cx="3872563" cy="1766960"/>
+              <a:off x="0" y="-76200"/>
+              <a:ext cx="3872563" cy="1805060"/>
             </a:xfrm>
             <a:prstGeom prst="rect">
               <a:avLst/>
@@ -16043,8 +16052,8 @@
           </p:nvSpPr>
           <p:spPr>
             <a:xfrm>
-              <a:off x="0" y="-38100"/>
-              <a:ext cx="3806266" cy="1729188"/>
+              <a:off x="0" y="-76200"/>
+              <a:ext cx="3806266" cy="1767288"/>
             </a:xfrm>
             <a:prstGeom prst="rect">
               <a:avLst/>
@@ -16542,8 +16551,8 @@
         </p:nvSpPr>
         <p:spPr>
           <a:xfrm rot="0">
-            <a:off x="4551980" y="895350"/>
-            <a:ext cx="9282825" cy="1047676"/>
+            <a:off x="4551980" y="790575"/>
+            <a:ext cx="9282825" cy="1152451"/>
           </a:xfrm>
           <a:prstGeom prst="rect">
             <a:avLst/>
@@ -16565,10 +16574,10 @@
                 <a:solidFill>
                   <a:srgbClr val="FFB9B9"/>
                 </a:solidFill>
-                <a:latin typeface="Bernoru"/>
-                <a:ea typeface="Bernoru"/>
-                <a:cs typeface="Bernoru"/>
-                <a:sym typeface="Bernoru"/>
+                <a:latin typeface="Times New Roman"/>
+                <a:ea typeface="Times New Roman"/>
+                <a:cs typeface="Times New Roman"/>
+                <a:sym typeface="Times New Roman"/>
               </a:rPr>
               <a:t> Hướng tiếp cận</a:t>
             </a:r>
@@ -16583,8 +16592,8 @@
         </p:nvSpPr>
         <p:spPr>
           <a:xfrm rot="0">
-            <a:off x="2990161" y="2282392"/>
-            <a:ext cx="13631368" cy="6169025"/>
+            <a:off x="2990161" y="2206192"/>
+            <a:ext cx="13631368" cy="6245225"/>
           </a:xfrm>
           <a:prstGeom prst="rect">
             <a:avLst/>
@@ -16604,28 +16613,16 @@
               <a:buChar char="•"/>
             </a:pPr>
             <a:r>
-              <a:rPr lang="en-US" b="true" sz="3500">
-                <a:solidFill>
-                  <a:srgbClr val="863434"/>
-                </a:solidFill>
-                <a:latin typeface="Canva Sans Bold"/>
-                <a:ea typeface="Canva Sans Bold"/>
-                <a:cs typeface="Canva Sans Bold"/>
-                <a:sym typeface="Canva Sans Bold"/>
-              </a:rPr>
-              <a:t>Mô hình thống kê truyền thống:</a:t>
-            </a:r>
-            <a:r>
               <a:rPr lang="en-US" sz="3500">
                 <a:solidFill>
                   <a:srgbClr val="863434"/>
                 </a:solidFill>
-                <a:latin typeface="Canva Sans"/>
-                <a:ea typeface="Canva Sans"/>
-                <a:cs typeface="Canva Sans"/>
-                <a:sym typeface="Canva Sans"/>
+                <a:latin typeface="Times New Roman"/>
+                <a:ea typeface="Times New Roman"/>
+                <a:cs typeface="Times New Roman"/>
+                <a:sym typeface="Times New Roman"/>
               </a:rPr>
-              <a:t> Các mô hình như ARIMA và Holt-Winters dựa trên các giả định về cấu trúc dữ liệu và được sử dụng rộng rãi trong phân tích chuỗi thời gian.</a:t>
+              <a:t>Mô hình thống kê truyền thống: Các mô hình như ARIMA và Holt-Winters dựa trên các giả định về cấu trúc dữ liệu và được sử dụng rộng rãi trong phân tích chuỗi thời gian.</a:t>
             </a:r>
           </a:p>
           <a:p>
@@ -16637,28 +16634,16 @@
               <a:buChar char="•"/>
             </a:pPr>
             <a:r>
-              <a:rPr lang="en-US" b="true" sz="3500">
-                <a:solidFill>
-                  <a:srgbClr val="863434"/>
-                </a:solidFill>
-                <a:latin typeface="Canva Sans Bold"/>
-                <a:ea typeface="Canva Sans Bold"/>
-                <a:cs typeface="Canva Sans Bold"/>
-                <a:sym typeface="Canva Sans Bold"/>
-              </a:rPr>
-              <a:t>Mô hình học máy:</a:t>
-            </a:r>
-            <a:r>
               <a:rPr lang="en-US" sz="3500">
                 <a:solidFill>
                   <a:srgbClr val="863434"/>
                 </a:solidFill>
-                <a:latin typeface="Canva Sans"/>
-                <a:ea typeface="Canva Sans"/>
-                <a:cs typeface="Canva Sans"/>
-                <a:sym typeface="Canva Sans"/>
+                <a:latin typeface="Times New Roman"/>
+                <a:ea typeface="Times New Roman"/>
+                <a:cs typeface="Times New Roman"/>
+                <a:sym typeface="Times New Roman"/>
               </a:rPr>
-              <a:t> Các thuật toán như Random Forest, XGBoost, và CatBoost khai thác mối quan hệ phức tạp trong dữ liệu để tạo ra dự báo chính xác hơn.</a:t>
+              <a:t>Mô hình học máy: Các thuật toán như Random Forest, XGBoost, và CatBoost khai thác mối quan hệ phức tạp trong dữ liệu để tạo ra dự báo chính xác hơn.</a:t>
             </a:r>
           </a:p>
           <a:p>
@@ -16670,28 +16655,16 @@
               <a:buChar char="•"/>
             </a:pPr>
             <a:r>
-              <a:rPr lang="en-US" b="true" sz="3500">
-                <a:solidFill>
-                  <a:srgbClr val="863434"/>
-                </a:solidFill>
-                <a:latin typeface="Canva Sans Bold"/>
-                <a:ea typeface="Canva Sans Bold"/>
-                <a:cs typeface="Canva Sans Bold"/>
-                <a:sym typeface="Canva Sans Bold"/>
-              </a:rPr>
-              <a:t>Mô hình học sâu:</a:t>
-            </a:r>
-            <a:r>
               <a:rPr lang="en-US" sz="3500">
                 <a:solidFill>
                   <a:srgbClr val="863434"/>
                 </a:solidFill>
-                <a:latin typeface="Canva Sans"/>
-                <a:ea typeface="Canva Sans"/>
-                <a:cs typeface="Canva Sans"/>
-                <a:sym typeface="Canva Sans"/>
+                <a:latin typeface="Times New Roman"/>
+                <a:ea typeface="Times New Roman"/>
+                <a:cs typeface="Times New Roman"/>
+                <a:sym typeface="Times New Roman"/>
               </a:rPr>
-              <a:t> Mạng nơ-ron hồi tiếp LSTM có khả năng học được các mẫu dữ liệu dài hạn và được sử dụng nhiều trong các bài toán dự báo chuỗi thời gian.</a:t>
+              <a:t>Mô hình học sâu: Mạng nơ-ron hồi tiếp LSTM có khả năng học được các mẫu dữ liệu dài hạn và được sử dụng nhiều trong các bài toán dự báo chuỗi thời gian.</a:t>
             </a:r>
           </a:p>
           <a:p>
@@ -18024,8 +17997,8 @@
         </p:nvSpPr>
         <p:spPr>
           <a:xfrm rot="0">
-            <a:off x="3216693" y="995186"/>
-            <a:ext cx="11999462" cy="924543"/>
+            <a:off x="3216693" y="899936"/>
+            <a:ext cx="11999462" cy="1017511"/>
           </a:xfrm>
           <a:prstGeom prst="rect">
             <a:avLst/>
@@ -18047,10 +18020,10 @@
                 <a:solidFill>
                   <a:srgbClr val="FFB9B9"/>
                 </a:solidFill>
-                <a:latin typeface="Bernoru"/>
-                <a:ea typeface="Bernoru"/>
-                <a:cs typeface="Bernoru"/>
-                <a:sym typeface="Bernoru"/>
+                <a:latin typeface="Times New Roman"/>
+                <a:ea typeface="Times New Roman"/>
+                <a:cs typeface="Times New Roman"/>
+                <a:sym typeface="Times New Roman"/>
               </a:rPr>
               <a:t>Phương pháp, kỹ thuật áp dụng</a:t>
             </a:r>
@@ -18065,8 +18038,8 @@
         </p:nvSpPr>
         <p:spPr>
           <a:xfrm rot="0">
-            <a:off x="3008466" y="2869660"/>
-            <a:ext cx="12415916" cy="4940300"/>
+            <a:off x="3008466" y="2802985"/>
+            <a:ext cx="12415916" cy="5006975"/>
           </a:xfrm>
           <a:prstGeom prst="rect">
             <a:avLst/>
@@ -18088,10 +18061,10 @@
                 <a:solidFill>
                   <a:srgbClr val="863434"/>
                 </a:solidFill>
-                <a:latin typeface="Glacial Indifference Bold"/>
-                <a:ea typeface="Glacial Indifference Bold"/>
-                <a:cs typeface="Glacial Indifference Bold"/>
-                <a:sym typeface="Glacial Indifference Bold"/>
+                <a:latin typeface="Times New Roman Bold"/>
+                <a:ea typeface="Times New Roman Bold"/>
+                <a:cs typeface="Times New Roman Bold"/>
+                <a:sym typeface="Times New Roman Bold"/>
               </a:rPr>
               <a:t>1. Mô hình thống kê</a:t>
             </a:r>
@@ -18109,10 +18082,10 @@
                 <a:solidFill>
                   <a:srgbClr val="863434"/>
                 </a:solidFill>
-                <a:latin typeface="Glacial Indifference Bold"/>
-                <a:ea typeface="Glacial Indifference Bold"/>
-                <a:cs typeface="Glacial Indifference Bold"/>
-                <a:sym typeface="Glacial Indifference Bold"/>
+                <a:latin typeface="Times New Roman Bold"/>
+                <a:ea typeface="Times New Roman Bold"/>
+                <a:cs typeface="Times New Roman Bold"/>
+                <a:sym typeface="Times New Roman Bold"/>
               </a:rPr>
               <a:t>ARIMA</a:t>
             </a:r>
@@ -18121,10 +18094,10 @@
                 <a:solidFill>
                   <a:srgbClr val="863434"/>
                 </a:solidFill>
-                <a:latin typeface="Glacial Indifference"/>
-                <a:ea typeface="Glacial Indifference"/>
-                <a:cs typeface="Glacial Indifference"/>
-                <a:sym typeface="Glacial Indifference"/>
+                <a:latin typeface="Times New Roman"/>
+                <a:ea typeface="Times New Roman"/>
+                <a:cs typeface="Times New Roman"/>
+                <a:sym typeface="Times New Roman"/>
               </a:rPr>
               <a:t>: Kết hợp hồi quy tự động (AR), tích hợp (I) và trung bình trượt (MA) để dự báo chuỗi thời gian không có yếu tố mùa vụ.</a:t>
             </a:r>
@@ -18142,10 +18115,10 @@
                 <a:solidFill>
                   <a:srgbClr val="863434"/>
                 </a:solidFill>
-                <a:latin typeface="Glacial Indifference Bold"/>
-                <a:ea typeface="Glacial Indifference Bold"/>
-                <a:cs typeface="Glacial Indifference Bold"/>
-                <a:sym typeface="Glacial Indifference Bold"/>
+                <a:latin typeface="Times New Roman Bold"/>
+                <a:ea typeface="Times New Roman Bold"/>
+                <a:cs typeface="Times New Roman Bold"/>
+                <a:sym typeface="Times New Roman Bold"/>
               </a:rPr>
               <a:t>Holt-Winters</a:t>
             </a:r>
@@ -18154,10 +18127,10 @@
                 <a:solidFill>
                   <a:srgbClr val="863434"/>
                 </a:solidFill>
-                <a:latin typeface="Glacial Indifference"/>
-                <a:ea typeface="Glacial Indifference"/>
-                <a:cs typeface="Glacial Indifference"/>
-                <a:sym typeface="Glacial Indifference"/>
+                <a:latin typeface="Times New Roman"/>
+                <a:ea typeface="Times New Roman"/>
+                <a:cs typeface="Times New Roman"/>
+                <a:sym typeface="Times New Roman"/>
               </a:rPr>
               <a:t>: Làm mượt dữ liệu theo ba thành phần: mức độ, xu hướng và mùa vụ, phù hợp với chuỗi thời gian có tính mùa vụ và xu hướng.</a:t>
             </a:r>
@@ -18211,7 +18184,7 @@
         </p:nvSpPr>
         <p:spPr>
           <a:xfrm flipH="false" flipV="false" rot="0">
-            <a:off x="-801280" y="8767349"/>
+            <a:off x="-782230" y="8767349"/>
             <a:ext cx="2890103" cy="2128167"/>
           </a:xfrm>
           <a:custGeom>
@@ -18263,7 +18236,7 @@
         </p:nvSpPr>
         <p:spPr>
           <a:xfrm flipH="false" flipV="false" rot="0">
-            <a:off x="1959440" y="8767349"/>
+            <a:off x="1978490" y="8767349"/>
             <a:ext cx="2319495" cy="1775468"/>
           </a:xfrm>
           <a:custGeom>
@@ -18315,7 +18288,7 @@
         </p:nvSpPr>
         <p:spPr>
           <a:xfrm flipH="false" flipV="false" rot="0">
-            <a:off x="14876269" y="-1217512"/>
+            <a:off x="14895319" y="-1217512"/>
             <a:ext cx="4766063" cy="2435025"/>
           </a:xfrm>
           <a:custGeom>
@@ -18367,7 +18340,7 @@
         </p:nvSpPr>
         <p:spPr>
           <a:xfrm flipH="false" flipV="false" rot="0">
-            <a:off x="13173010" y="-240039"/>
+            <a:off x="13192060" y="-240039"/>
             <a:ext cx="4086290" cy="2087723"/>
           </a:xfrm>
           <a:custGeom>
@@ -18419,7 +18392,7 @@
         </p:nvSpPr>
         <p:spPr>
           <a:xfrm flipH="false" flipV="false" rot="0">
-            <a:off x="-1014445" y="-870210"/>
+            <a:off x="-995395" y="-870210"/>
             <a:ext cx="4086290" cy="2087723"/>
           </a:xfrm>
           <a:custGeom>
@@ -18471,7 +18444,7 @@
         </p:nvSpPr>
         <p:spPr>
           <a:xfrm flipH="false" flipV="false" rot="0">
-            <a:off x="1596846" y="-512903"/>
+            <a:off x="1615896" y="-512903"/>
             <a:ext cx="4086290" cy="2087723"/>
           </a:xfrm>
           <a:custGeom>
@@ -18523,7 +18496,7 @@
         </p:nvSpPr>
         <p:spPr>
           <a:xfrm flipH="false" flipV="false" rot="0">
-            <a:off x="4278935" y="-870210"/>
+            <a:off x="4297985" y="-870210"/>
             <a:ext cx="3032933" cy="1549553"/>
           </a:xfrm>
           <a:custGeom>
@@ -18575,7 +18548,7 @@
         </p:nvSpPr>
         <p:spPr>
           <a:xfrm flipH="false" flipV="false" rot="0">
-            <a:off x="3654267" y="9148016"/>
+            <a:off x="3673317" y="9148016"/>
             <a:ext cx="5055817" cy="1833503"/>
           </a:xfrm>
           <a:custGeom>
@@ -18627,7 +18600,7 @@
         </p:nvSpPr>
         <p:spPr>
           <a:xfrm flipH="false" flipV="false" rot="0">
-            <a:off x="-854015" y="1847684"/>
+            <a:off x="-834965" y="1847684"/>
             <a:ext cx="1708029" cy="1813341"/>
           </a:xfrm>
           <a:custGeom>
@@ -18679,7 +18652,7 @@
         </p:nvSpPr>
         <p:spPr>
           <a:xfrm flipH="false" flipV="false" rot="0">
-            <a:off x="3654267" y="8682374"/>
+            <a:off x="3673317" y="8682374"/>
             <a:ext cx="638944" cy="636620"/>
           </a:xfrm>
           <a:custGeom>
@@ -18731,7 +18704,7 @@
         </p:nvSpPr>
         <p:spPr>
           <a:xfrm flipH="false" flipV="false" rot="2699999">
-            <a:off x="764025" y="8141822"/>
+            <a:off x="783075" y="8141822"/>
             <a:ext cx="535412" cy="511075"/>
           </a:xfrm>
           <a:custGeom>
@@ -18783,7 +18756,7 @@
         </p:nvGrpSpPr>
         <p:grpSpPr>
           <a:xfrm rot="0">
-            <a:off x="2273298" y="2275901"/>
+            <a:off x="2292348" y="2275901"/>
             <a:ext cx="13889521" cy="6624920"/>
             <a:chOff x="0" y="0"/>
             <a:chExt cx="18519361" cy="8833227"/>
@@ -19024,7 +18997,7 @@
         </p:nvSpPr>
         <p:spPr>
           <a:xfrm flipH="false" flipV="false" rot="-279302">
-            <a:off x="17446073" y="8053096"/>
+            <a:off x="17465123" y="8053096"/>
             <a:ext cx="577600" cy="321356"/>
           </a:xfrm>
           <a:custGeom>
@@ -19076,7 +19049,7 @@
         </p:nvSpPr>
         <p:spPr>
           <a:xfrm flipH="false" flipV="false" rot="0">
-            <a:off x="15894029" y="7804292"/>
+            <a:off x="15913079" y="7804292"/>
             <a:ext cx="537577" cy="577476"/>
           </a:xfrm>
           <a:custGeom>
@@ -19128,7 +19101,7 @@
         </p:nvSpPr>
         <p:spPr>
           <a:xfrm flipH="false" flipV="false" rot="0">
-            <a:off x="10376218" y="8836091"/>
+            <a:off x="10395268" y="8836091"/>
             <a:ext cx="1186499" cy="2392800"/>
           </a:xfrm>
           <a:custGeom>
@@ -19180,7 +19153,7 @@
         </p:nvSpPr>
         <p:spPr>
           <a:xfrm flipH="false" flipV="false" rot="0">
-            <a:off x="11562717" y="9148016"/>
+            <a:off x="11581767" y="9148016"/>
             <a:ext cx="1713492" cy="1833503"/>
           </a:xfrm>
           <a:custGeom>
@@ -19232,7 +19205,7 @@
         </p:nvSpPr>
         <p:spPr>
           <a:xfrm flipH="false" flipV="false" rot="0">
-            <a:off x="7698948" y="9000684"/>
+            <a:off x="7717998" y="9000684"/>
             <a:ext cx="2890103" cy="2128167"/>
           </a:xfrm>
           <a:custGeom>
@@ -19284,7 +19257,7 @@
         </p:nvSpPr>
         <p:spPr>
           <a:xfrm flipH="false" flipV="false" rot="0">
-            <a:off x="13173010" y="8502716"/>
+            <a:off x="13192060" y="8502716"/>
             <a:ext cx="2665215" cy="2040101"/>
           </a:xfrm>
           <a:custGeom>
@@ -19336,7 +19309,7 @@
         </p:nvSpPr>
         <p:spPr>
           <a:xfrm flipH="false" flipV="false" rot="0">
-            <a:off x="16621528" y="8381804"/>
+            <a:off x="16640578" y="8381804"/>
             <a:ext cx="2192793" cy="2634625"/>
           </a:xfrm>
           <a:custGeom>
@@ -19388,7 +19361,7 @@
         </p:nvSpPr>
         <p:spPr>
           <a:xfrm flipH="false" flipV="false" rot="0">
-            <a:off x="15448209" y="8590782"/>
+            <a:off x="15467259" y="8590782"/>
             <a:ext cx="1173319" cy="2304734"/>
           </a:xfrm>
           <a:custGeom>
@@ -19440,7 +19413,7 @@
         </p:nvSpPr>
         <p:spPr>
           <a:xfrm flipH="false" flipV="false" rot="0">
-            <a:off x="17433985" y="4681691"/>
+            <a:off x="17453035" y="4681691"/>
             <a:ext cx="1708029" cy="1813341"/>
           </a:xfrm>
           <a:custGeom>
@@ -19492,8 +19465,8 @@
         </p:nvSpPr>
         <p:spPr>
           <a:xfrm rot="0">
-            <a:off x="3216693" y="995186"/>
-            <a:ext cx="11999462" cy="924543"/>
+            <a:off x="3235743" y="899936"/>
+            <a:ext cx="11999462" cy="1017511"/>
           </a:xfrm>
           <a:prstGeom prst="rect">
             <a:avLst/>
@@ -19515,10 +19488,10 @@
                 <a:solidFill>
                   <a:srgbClr val="FFB9B9"/>
                 </a:solidFill>
-                <a:latin typeface="Bernoru"/>
-                <a:ea typeface="Bernoru"/>
-                <a:cs typeface="Bernoru"/>
-                <a:sym typeface="Bernoru"/>
+                <a:latin typeface="Times New Roman"/>
+                <a:ea typeface="Times New Roman"/>
+                <a:cs typeface="Times New Roman"/>
+                <a:sym typeface="Times New Roman"/>
               </a:rPr>
               <a:t>Phương pháp, kỹ thuật áp dụng</a:t>
             </a:r>
@@ -19533,8 +19506,8 @@
         </p:nvSpPr>
         <p:spPr>
           <a:xfrm rot="0">
-            <a:off x="3008466" y="2869660"/>
-            <a:ext cx="12415916" cy="5559425"/>
+            <a:off x="3027516" y="2802985"/>
+            <a:ext cx="12415916" cy="5626100"/>
           </a:xfrm>
           <a:prstGeom prst="rect">
             <a:avLst/>
@@ -19556,10 +19529,10 @@
                 <a:solidFill>
                   <a:srgbClr val="863434"/>
                 </a:solidFill>
-                <a:latin typeface="Glacial Indifference Bold"/>
-                <a:ea typeface="Glacial Indifference Bold"/>
-                <a:cs typeface="Glacial Indifference Bold"/>
-                <a:sym typeface="Glacial Indifference Bold"/>
+                <a:latin typeface="Times New Roman Bold"/>
+                <a:ea typeface="Times New Roman Bold"/>
+                <a:cs typeface="Times New Roman Bold"/>
+                <a:sym typeface="Times New Roman Bold"/>
               </a:rPr>
               <a:t>2. Mô hình học máy</a:t>
             </a:r>
@@ -19577,10 +19550,10 @@
                 <a:solidFill>
                   <a:srgbClr val="863434"/>
                 </a:solidFill>
-                <a:latin typeface="Glacial Indifference Bold"/>
-                <a:ea typeface="Glacial Indifference Bold"/>
-                <a:cs typeface="Glacial Indifference Bold"/>
-                <a:sym typeface="Glacial Indifference Bold"/>
+                <a:latin typeface="Times New Roman Bold"/>
+                <a:ea typeface="Times New Roman Bold"/>
+                <a:cs typeface="Times New Roman Bold"/>
+                <a:sym typeface="Times New Roman Bold"/>
               </a:rPr>
               <a:t>Random Forest: </a:t>
             </a:r>
@@ -19589,10 +19562,10 @@
                 <a:solidFill>
                   <a:srgbClr val="863434"/>
                 </a:solidFill>
-                <a:latin typeface="Glacial Indifference"/>
-                <a:ea typeface="Glacial Indifference"/>
-                <a:cs typeface="Glacial Indifference"/>
-                <a:sym typeface="Glacial Indifference"/>
+                <a:latin typeface="Times New Roman"/>
+                <a:ea typeface="Times New Roman"/>
+                <a:cs typeface="Times New Roman"/>
+                <a:sym typeface="Times New Roman"/>
               </a:rPr>
               <a:t>Sử dụng nhiều cây quyết định để giảm sai số, phù hợp với dữ liệu lớn.</a:t>
             </a:r>
@@ -19610,10 +19583,10 @@
                 <a:solidFill>
                   <a:srgbClr val="863434"/>
                 </a:solidFill>
-                <a:latin typeface="Glacial Indifference Bold"/>
-                <a:ea typeface="Glacial Indifference Bold"/>
-                <a:cs typeface="Glacial Indifference Bold"/>
-                <a:sym typeface="Glacial Indifference Bold"/>
+                <a:latin typeface="Times New Roman Bold"/>
+                <a:ea typeface="Times New Roman Bold"/>
+                <a:cs typeface="Times New Roman Bold"/>
+                <a:sym typeface="Times New Roman Bold"/>
               </a:rPr>
               <a:t>XGBoost: </a:t>
             </a:r>
@@ -19622,10 +19595,10 @@
                 <a:solidFill>
                   <a:srgbClr val="863434"/>
                 </a:solidFill>
-                <a:latin typeface="Glacial Indifference"/>
-                <a:ea typeface="Glacial Indifference"/>
-                <a:cs typeface="Glacial Indifference"/>
-                <a:sym typeface="Glacial Indifference"/>
+                <a:latin typeface="Times New Roman"/>
+                <a:ea typeface="Times New Roman"/>
+                <a:cs typeface="Times New Roman"/>
+                <a:sym typeface="Times New Roman"/>
               </a:rPr>
               <a:t>Thuật toán boosting tối ưu hóa sai số, hiệu quả với dữ liệu phức tạp.</a:t>
             </a:r>
@@ -19643,10 +19616,10 @@
                 <a:solidFill>
                   <a:srgbClr val="863434"/>
                 </a:solidFill>
-                <a:latin typeface="Glacial Indifference Bold"/>
-                <a:ea typeface="Glacial Indifference Bold"/>
-                <a:cs typeface="Glacial Indifference Bold"/>
-                <a:sym typeface="Glacial Indifference Bold"/>
+                <a:latin typeface="Times New Roman Bold"/>
+                <a:ea typeface="Times New Roman Bold"/>
+                <a:cs typeface="Times New Roman Bold"/>
+                <a:sym typeface="Times New Roman Bold"/>
               </a:rPr>
               <a:t>CatBoost: </a:t>
             </a:r>
@@ -19655,10 +19628,10 @@
                 <a:solidFill>
                   <a:srgbClr val="863434"/>
                 </a:solidFill>
-                <a:latin typeface="Glacial Indifference"/>
-                <a:ea typeface="Glacial Indifference"/>
-                <a:cs typeface="Glacial Indifference"/>
-                <a:sym typeface="Glacial Indifference"/>
+                <a:latin typeface="Times New Roman"/>
+                <a:ea typeface="Times New Roman"/>
+                <a:cs typeface="Times New Roman"/>
+                <a:sym typeface="Times New Roman"/>
               </a:rPr>
               <a:t>Boosting cải tiến cho dữ liệu có nhiều đặc trưng phân loại, giảm overfitting.</a:t>
             </a:r>

</xml_diff>